<commit_message>
feat(android): add ECG-style side wave animation on timer
- Implement continuous fade wave animation outside timer arc (left/right) while session is running
- Keep existing timer arc and text transitions unchanged

Made-with: Cursor
</commit_message>
<xml_diff>
--- a/docs/presentation/KARA_Prezentare.pptx
+++ b/docs/presentation/KARA_Prezentare.pptx
@@ -5,7 +5,7 @@
     <p:sldMasterId id="2147483648" r:id="rId1"/>
   </p:sldMasterIdLst>
   <p:notesMasterIdLst>
-    <p:notesMasterId r:id="rId11"/>
+    <p:notesMasterId r:id="rId10"/>
   </p:notesMasterIdLst>
   <p:sldIdLst>
     <p:sldId id="256" r:id="rId2"/>
@@ -15,8 +15,7 @@
     <p:sldId id="260" r:id="rId6"/>
     <p:sldId id="261" r:id="rId7"/>
     <p:sldId id="262" r:id="rId8"/>
-    <p:sldId id="263" r:id="rId9"/>
-    <p:sldId id="264" r:id="rId10"/>
+    <p:sldId id="264" r:id="rId9"/>
   </p:sldIdLst>
   <p:sldSz cx="9144000" cy="5143500" type="screen16x9"/>
   <p:notesSz cx="5143500" cy="9144000"/>
@@ -917,90 +916,6 @@
 </p:notes>
 </file>
 
-<file path=ppt/notesSlides/notesSlide9.xml><?xml version="1.0" encoding="utf-8"?>
-<p:notes xmlns:a="http://schemas.openxmlformats.org/drawingml/2006/main" xmlns:r="http://schemas.openxmlformats.org/officeDocument/2006/relationships" xmlns:p="http://schemas.openxmlformats.org/presentationml/2006/main">
-  <p:cSld>
-    <p:spTree>
-      <p:nvGrpSpPr>
-        <p:cNvPr id="1" name=""/>
-        <p:cNvGrpSpPr/>
-        <p:nvPr/>
-      </p:nvGrpSpPr>
-      <p:grpSpPr>
-        <a:xfrm>
-          <a:off x="0" y="0"/>
-          <a:ext cx="0" cy="0"/>
-          <a:chOff x="0" y="0"/>
-          <a:chExt cx="0" cy="0"/>
-        </a:xfrm>
-      </p:grpSpPr>
-      <p:sp>
-        <p:nvSpPr>
-          <p:cNvPr id="2" name="Slide Image Placeholder 1"/>
-          <p:cNvSpPr>
-            <a:spLocks noGrp="1" noRot="1" noChangeAspect="1"/>
-          </p:cNvSpPr>
-          <p:nvPr>
-            <p:ph type="sldImg"/>
-          </p:nvPr>
-        </p:nvSpPr>
-        <p:spPr/>
-      </p:sp>
-      <p:sp>
-        <p:nvSpPr>
-          <p:cNvPr id="3" name="Notes Placeholder 2"/>
-          <p:cNvSpPr>
-            <a:spLocks noGrp="1"/>
-          </p:cNvSpPr>
-          <p:nvPr>
-            <p:ph type="body" idx="1"/>
-          </p:nvPr>
-        </p:nvSpPr>
-        <p:spPr/>
-        <p:txBody>
-          <a:bodyPr/>
-          <a:lstStyle/>
-          <a:p>
-            <a:endParaRPr lang="en-US" dirty="0"/>
-          </a:p>
-        </p:txBody>
-      </p:sp>
-      <p:sp>
-        <p:nvSpPr>
-          <p:cNvPr id="4" name="Slide Number Placeholder 3"/>
-          <p:cNvSpPr>
-            <a:spLocks noGrp="1"/>
-          </p:cNvSpPr>
-          <p:nvPr>
-            <p:ph type="sldNum" sz="quarter" idx="10"/>
-          </p:nvPr>
-        </p:nvSpPr>
-        <p:spPr/>
-        <p:txBody>
-          <a:bodyPr/>
-          <a:lstStyle/>
-          <a:p>
-            <a:fld id="{F7021451-1387-4CA6-816F-3879F97B5CBC}" type="slidenum">
-              <a:rPr lang="en-US"/>
-              <a:t>9</a:t>
-            </a:fld>
-            <a:endParaRPr lang="en-US"/>
-          </a:p>
-        </p:txBody>
-      </p:sp>
-    </p:spTree>
-    <p:extLst>
-      <p:ext uri="{BB962C8B-B14F-4D97-AF65-F5344CB8AC3E}">
-        <p14:creationId xmlns:p14="http://schemas.microsoft.com/office/powerpoint/2010/main" val="1024086991"/>
-      </p:ext>
-    </p:extLst>
-  </p:cSld>
-  <p:clrMapOvr>
-    <a:masterClrMapping/>
-  </p:clrMapOvr>
-</p:notes>
-</file>
-
 <file path=ppt/slideLayouts/slideLayout1.xml><?xml version="1.0" encoding="utf-8"?>
 <p:sldLayout xmlns:a="http://schemas.openxmlformats.org/drawingml/2006/main" xmlns:r="http://schemas.openxmlformats.org/officeDocument/2006/relationships" xmlns:p="http://schemas.openxmlformats.org/presentationml/2006/main" preserve="1">
   <p:cSld name="DEFAULT">
@@ -6470,887 +6385,6 @@
 </file>
 
 <file path=ppt/slides/slide8.xml><?xml version="1.0" encoding="utf-8"?>
-<p:sld xmlns:a="http://schemas.openxmlformats.org/drawingml/2006/main" xmlns:r="http://schemas.openxmlformats.org/officeDocument/2006/relationships" xmlns:p="http://schemas.openxmlformats.org/presentationml/2006/main">
-  <p:cSld name="Slide 8">
-    <p:bg>
-      <p:bgPr>
-        <a:solidFill>
-          <a:srgbClr val="0A0E1A"/>
-        </a:solidFill>
-        <a:effectLst/>
-      </p:bgPr>
-    </p:bg>
-    <p:spTree>
-      <p:nvGrpSpPr>
-        <p:cNvPr id="1" name=""/>
-        <p:cNvGrpSpPr/>
-        <p:nvPr/>
-      </p:nvGrpSpPr>
-      <p:grpSpPr>
-        <a:xfrm>
-          <a:off x="0" y="0"/>
-          <a:ext cx="0" cy="0"/>
-          <a:chOff x="0" y="0"/>
-          <a:chExt cx="0" cy="0"/>
-        </a:xfrm>
-      </p:grpSpPr>
-      <p:sp>
-        <p:nvSpPr>
-          <p:cNvPr id="2" name="Shape 0"/>
-          <p:cNvSpPr/>
-          <p:nvPr/>
-        </p:nvSpPr>
-        <p:spPr>
-          <a:xfrm>
-            <a:off x="0" y="0"/>
-            <a:ext cx="9144000" cy="54864"/>
-          </a:xfrm>
-          <a:prstGeom prst="rect">
-            <a:avLst/>
-          </a:prstGeom>
-          <a:solidFill>
-            <a:srgbClr val="00C4D4"/>
-          </a:solidFill>
-          <a:ln/>
-        </p:spPr>
-      </p:sp>
-      <p:sp>
-        <p:nvSpPr>
-          <p:cNvPr id="3" name="Text 1"/>
-          <p:cNvSpPr/>
-          <p:nvPr/>
-        </p:nvSpPr>
-        <p:spPr>
-          <a:xfrm>
-            <a:off x="457200" y="164592"/>
-            <a:ext cx="4572000" cy="292608"/>
-          </a:xfrm>
-          <a:prstGeom prst="rect">
-            <a:avLst/>
-          </a:prstGeom>
-          <a:noFill/>
-          <a:ln/>
-        </p:spPr>
-        <p:txBody>
-          <a:bodyPr wrap="square" lIns="0" tIns="0" rIns="0" bIns="0" rtlCol="0" anchor="ctr"/>
-          <a:lstStyle/>
-          <a:p>
-            <a:pPr marL="0" indent="0">
-              <a:buNone/>
-            </a:pPr>
-            <a:r>
-              <a:rPr lang="en-US" sz="900" b="1" kern="0" spc="400" dirty="0">
-                <a:solidFill>
-                  <a:srgbClr val="00C4D4"/>
-                </a:solidFill>
-                <a:latin typeface="Calibri" pitchFamily="34" charset="0"/>
-                <a:ea typeface="Calibri" pitchFamily="34" charset="-122"/>
-                <a:cs typeface="Calibri" pitchFamily="34" charset="-120"/>
-              </a:rPr>
-              <a:t>BUSINESS MODEL</a:t>
-            </a:r>
-            <a:endParaRPr lang="en-US" sz="900" dirty="0"/>
-          </a:p>
-        </p:txBody>
-      </p:sp>
-      <p:sp>
-        <p:nvSpPr>
-          <p:cNvPr id="4" name="Text 2"/>
-          <p:cNvSpPr/>
-          <p:nvPr/>
-        </p:nvSpPr>
-        <p:spPr>
-          <a:xfrm>
-            <a:off x="457200" y="475488"/>
-            <a:ext cx="8229600" cy="502920"/>
-          </a:xfrm>
-          <a:prstGeom prst="rect">
-            <a:avLst/>
-          </a:prstGeom>
-          <a:noFill/>
-          <a:ln/>
-        </p:spPr>
-        <p:txBody>
-          <a:bodyPr wrap="square" lIns="0" tIns="0" rIns="0" bIns="0" rtlCol="0" anchor="ctr"/>
-          <a:lstStyle/>
-          <a:p>
-            <a:pPr marL="0" indent="0">
-              <a:buNone/>
-            </a:pPr>
-            <a:r>
-              <a:rPr lang="en-US" sz="2600" b="1" dirty="0">
-                <a:solidFill>
-                  <a:srgbClr val="FFFFFF"/>
-                </a:solidFill>
-                <a:latin typeface="Calibri" pitchFamily="34" charset="0"/>
-                <a:ea typeface="Calibri" pitchFamily="34" charset="-122"/>
-                <a:cs typeface="Calibri" pitchFamily="34" charset="-120"/>
-              </a:rPr>
-              <a:t>Model Freemium</a:t>
-            </a:r>
-            <a:endParaRPr lang="en-US" sz="2600" dirty="0"/>
-          </a:p>
-        </p:txBody>
-      </p:sp>
-      <p:sp>
-        <p:nvSpPr>
-          <p:cNvPr id="5" name="Shape 3"/>
-          <p:cNvSpPr/>
-          <p:nvPr/>
-        </p:nvSpPr>
-        <p:spPr>
-          <a:xfrm>
-            <a:off x="457200" y="1143000"/>
-            <a:ext cx="3840480" cy="3520440"/>
-          </a:xfrm>
-          <a:prstGeom prst="rect">
-            <a:avLst/>
-          </a:prstGeom>
-          <a:solidFill>
-            <a:srgbClr val="151E2E"/>
-          </a:solidFill>
-          <a:ln w="12700">
-            <a:solidFill>
-              <a:srgbClr val="8892A4">
-                <a:alpha val="50000"/>
-              </a:srgbClr>
-            </a:solidFill>
-            <a:prstDash val="solid"/>
-          </a:ln>
-          <a:effectLst>
-            <a:outerShdw blurRad="152400" dist="50800" dir="8100000" algn="bl" rotWithShape="0">
-              <a:srgbClr val="000000">
-                <a:alpha val="40000"/>
-              </a:srgbClr>
-            </a:outerShdw>
-          </a:effectLst>
-        </p:spPr>
-      </p:sp>
-      <p:sp>
-        <p:nvSpPr>
-          <p:cNvPr id="6" name="Shape 4"/>
-          <p:cNvSpPr/>
-          <p:nvPr/>
-        </p:nvSpPr>
-        <p:spPr>
-          <a:xfrm>
-            <a:off x="457200" y="1143000"/>
-            <a:ext cx="3840480" cy="54864"/>
-          </a:xfrm>
-          <a:prstGeom prst="rect">
-            <a:avLst/>
-          </a:prstGeom>
-          <a:solidFill>
-            <a:srgbClr val="8892A4"/>
-          </a:solidFill>
-          <a:ln/>
-        </p:spPr>
-      </p:sp>
-      <p:sp>
-        <p:nvSpPr>
-          <p:cNvPr id="7" name="Text 5"/>
-          <p:cNvSpPr/>
-          <p:nvPr/>
-        </p:nvSpPr>
-        <p:spPr>
-          <a:xfrm>
-            <a:off x="548640" y="1261872"/>
-            <a:ext cx="3657600" cy="411480"/>
-          </a:xfrm>
-          <a:prstGeom prst="rect">
-            <a:avLst/>
-          </a:prstGeom>
-          <a:noFill/>
-          <a:ln/>
-        </p:spPr>
-        <p:txBody>
-          <a:bodyPr wrap="square" lIns="0" tIns="0" rIns="0" bIns="0" rtlCol="0" anchor="ctr"/>
-          <a:lstStyle/>
-          <a:p>
-            <a:pPr marL="0" indent="0" algn="ctr">
-              <a:buNone/>
-            </a:pPr>
-            <a:r>
-              <a:rPr lang="en-US" sz="2000" b="1" dirty="0">
-                <a:solidFill>
-                  <a:srgbClr val="C8D0DC"/>
-                </a:solidFill>
-                <a:latin typeface="Calibri" pitchFamily="34" charset="0"/>
-                <a:ea typeface="Calibri" pitchFamily="34" charset="-122"/>
-                <a:cs typeface="Calibri" pitchFamily="34" charset="-120"/>
-              </a:rPr>
-              <a:t>FREE</a:t>
-            </a:r>
-            <a:endParaRPr lang="en-US" sz="2000" dirty="0"/>
-          </a:p>
-        </p:txBody>
-      </p:sp>
-      <p:sp>
-        <p:nvSpPr>
-          <p:cNvPr id="8" name="Text 6"/>
-          <p:cNvSpPr/>
-          <p:nvPr/>
-        </p:nvSpPr>
-        <p:spPr>
-          <a:xfrm>
-            <a:off x="548640" y="1691640"/>
-            <a:ext cx="3657600" cy="457200"/>
-          </a:xfrm>
-          <a:prstGeom prst="rect">
-            <a:avLst/>
-          </a:prstGeom>
-          <a:noFill/>
-          <a:ln/>
-        </p:spPr>
-        <p:txBody>
-          <a:bodyPr wrap="square" lIns="0" tIns="0" rIns="0" bIns="0" rtlCol="0" anchor="ctr"/>
-          <a:lstStyle/>
-          <a:p>
-            <a:pPr marL="0" indent="0" algn="ctr">
-              <a:buNone/>
-            </a:pPr>
-            <a:r>
-              <a:rPr lang="en-US" sz="3000" b="1" dirty="0">
-                <a:solidFill>
-                  <a:srgbClr val="FFFFFF"/>
-                </a:solidFill>
-                <a:latin typeface="Calibri" pitchFamily="34" charset="0"/>
-                <a:ea typeface="Calibri" pitchFamily="34" charset="-122"/>
-                <a:cs typeface="Calibri" pitchFamily="34" charset="-120"/>
-              </a:rPr>
-              <a:t>€0</a:t>
-            </a:r>
-            <a:endParaRPr lang="en-US" sz="3000" dirty="0"/>
-          </a:p>
-        </p:txBody>
-      </p:sp>
-      <p:sp>
-        <p:nvSpPr>
-          <p:cNvPr id="9" name="Text 7"/>
-          <p:cNvSpPr/>
-          <p:nvPr/>
-        </p:nvSpPr>
-        <p:spPr>
-          <a:xfrm>
-            <a:off x="640080" y="2304288"/>
-            <a:ext cx="3566160" cy="329184"/>
-          </a:xfrm>
-          <a:prstGeom prst="rect">
-            <a:avLst/>
-          </a:prstGeom>
-          <a:noFill/>
-          <a:ln/>
-        </p:spPr>
-        <p:txBody>
-          <a:bodyPr wrap="square" lIns="0" tIns="0" rIns="0" bIns="0" rtlCol="0" anchor="ctr"/>
-          <a:lstStyle/>
-          <a:p>
-            <a:pPr marL="0" indent="0">
-              <a:buNone/>
-            </a:pPr>
-            <a:r>
-              <a:rPr lang="en-US" sz="1200" dirty="0">
-                <a:solidFill>
-                  <a:srgbClr val="C8D0DC"/>
-                </a:solidFill>
-                <a:latin typeface="Calibri" pitchFamily="34" charset="0"/>
-                <a:ea typeface="Calibri" pitchFamily="34" charset="-122"/>
-                <a:cs typeface="Calibri" pitchFamily="34" charset="-120"/>
-              </a:rPr>
-              <a:t>✓  Timer 25/5 min fix</a:t>
-            </a:r>
-            <a:endParaRPr lang="en-US" sz="1200" dirty="0"/>
-          </a:p>
-        </p:txBody>
-      </p:sp>
-      <p:sp>
-        <p:nvSpPr>
-          <p:cNvPr id="10" name="Text 8"/>
-          <p:cNvSpPr/>
-          <p:nvPr/>
-        </p:nvSpPr>
-        <p:spPr>
-          <a:xfrm>
-            <a:off x="640080" y="2688336"/>
-            <a:ext cx="3566160" cy="329184"/>
-          </a:xfrm>
-          <a:prstGeom prst="rect">
-            <a:avLst/>
-          </a:prstGeom>
-          <a:noFill/>
-          <a:ln/>
-        </p:spPr>
-        <p:txBody>
-          <a:bodyPr wrap="square" lIns="0" tIns="0" rIns="0" bIns="0" rtlCol="0" anchor="ctr"/>
-          <a:lstStyle/>
-          <a:p>
-            <a:pPr marL="0" indent="0">
-              <a:buNone/>
-            </a:pPr>
-            <a:r>
-              <a:rPr lang="en-US" sz="1200" dirty="0">
-                <a:solidFill>
-                  <a:srgbClr val="C8D0DC"/>
-                </a:solidFill>
-                <a:latin typeface="Calibri" pitchFamily="34" charset="0"/>
-                <a:ea typeface="Calibri" pitchFamily="34" charset="-122"/>
-                <a:cs typeface="Calibri" pitchFamily="34" charset="-120"/>
-              </a:rPr>
-              <a:t>✓  Statistici 7 zile</a:t>
-            </a:r>
-            <a:endParaRPr lang="en-US" sz="1200" dirty="0"/>
-          </a:p>
-        </p:txBody>
-      </p:sp>
-      <p:sp>
-        <p:nvSpPr>
-          <p:cNvPr id="11" name="Text 9"/>
-          <p:cNvSpPr/>
-          <p:nvPr/>
-        </p:nvSpPr>
-        <p:spPr>
-          <a:xfrm>
-            <a:off x="640080" y="3072384"/>
-            <a:ext cx="3566160" cy="329184"/>
-          </a:xfrm>
-          <a:prstGeom prst="rect">
-            <a:avLst/>
-          </a:prstGeom>
-          <a:noFill/>
-          <a:ln/>
-        </p:spPr>
-        <p:txBody>
-          <a:bodyPr wrap="square" lIns="0" tIns="0" rIns="0" bIns="0" rtlCol="0" anchor="ctr"/>
-          <a:lstStyle/>
-          <a:p>
-            <a:pPr marL="0" indent="0">
-              <a:buNone/>
-            </a:pPr>
-            <a:r>
-              <a:rPr lang="en-US" sz="1200" dirty="0">
-                <a:solidFill>
-                  <a:srgbClr val="C8D0DC"/>
-                </a:solidFill>
-                <a:latin typeface="Calibri" pitchFamily="34" charset="0"/>
-                <a:ea typeface="Calibri" pitchFamily="34" charset="-122"/>
-                <a:cs typeface="Calibri" pitchFamily="34" charset="-120"/>
-              </a:rPr>
-              <a:t>✓  Max 5 task-uri active</a:t>
-            </a:r>
-            <a:endParaRPr lang="en-US" sz="1200" dirty="0"/>
-          </a:p>
-        </p:txBody>
-      </p:sp>
-      <p:sp>
-        <p:nvSpPr>
-          <p:cNvPr id="12" name="Text 10"/>
-          <p:cNvSpPr/>
-          <p:nvPr/>
-        </p:nvSpPr>
-        <p:spPr>
-          <a:xfrm>
-            <a:off x="640080" y="3456432"/>
-            <a:ext cx="3566160" cy="329184"/>
-          </a:xfrm>
-          <a:prstGeom prst="rect">
-            <a:avLst/>
-          </a:prstGeom>
-          <a:noFill/>
-          <a:ln/>
-        </p:spPr>
-        <p:txBody>
-          <a:bodyPr wrap="square" lIns="0" tIns="0" rIns="0" bIns="0" rtlCol="0" anchor="ctr"/>
-          <a:lstStyle/>
-          <a:p>
-            <a:pPr marL="0" indent="0">
-              <a:buNone/>
-            </a:pPr>
-            <a:r>
-              <a:rPr lang="en-US" sz="1200" dirty="0">
-                <a:solidFill>
-                  <a:srgbClr val="C8D0DC"/>
-                </a:solidFill>
-                <a:latin typeface="Calibri" pitchFamily="34" charset="0"/>
-                <a:ea typeface="Calibri" pitchFamily="34" charset="-122"/>
-                <a:cs typeface="Calibri" pitchFamily="34" charset="-120"/>
-              </a:rPr>
-              <a:t>✓  3 gesturi giroscop</a:t>
-            </a:r>
-            <a:endParaRPr lang="en-US" sz="1200" dirty="0"/>
-          </a:p>
-        </p:txBody>
-      </p:sp>
-      <p:sp>
-        <p:nvSpPr>
-          <p:cNvPr id="13" name="Text 11"/>
-          <p:cNvSpPr/>
-          <p:nvPr/>
-        </p:nvSpPr>
-        <p:spPr>
-          <a:xfrm>
-            <a:off x="640080" y="3840480"/>
-            <a:ext cx="3566160" cy="329184"/>
-          </a:xfrm>
-          <a:prstGeom prst="rect">
-            <a:avLst/>
-          </a:prstGeom>
-          <a:noFill/>
-          <a:ln/>
-        </p:spPr>
-        <p:txBody>
-          <a:bodyPr wrap="square" lIns="0" tIns="0" rIns="0" bIns="0" rtlCol="0" anchor="ctr"/>
-          <a:lstStyle/>
-          <a:p>
-            <a:pPr marL="0" indent="0">
-              <a:buNone/>
-            </a:pPr>
-            <a:r>
-              <a:rPr lang="en-US" sz="1200" dirty="0">
-                <a:solidFill>
-                  <a:srgbClr val="C8D0DC"/>
-                </a:solidFill>
-                <a:latin typeface="Calibri" pitchFamily="34" charset="0"/>
-                <a:ea typeface="Calibri" pitchFamily="34" charset="-122"/>
-                <a:cs typeface="Calibri" pitchFamily="34" charset="-120"/>
-              </a:rPr>
-              <a:t>✓  5 achievements de bază</a:t>
-            </a:r>
-            <a:endParaRPr lang="en-US" sz="1200" dirty="0"/>
-          </a:p>
-        </p:txBody>
-      </p:sp>
-      <p:sp>
-        <p:nvSpPr>
-          <p:cNvPr id="14" name="Shape 12"/>
-          <p:cNvSpPr/>
-          <p:nvPr/>
-        </p:nvSpPr>
-        <p:spPr>
-          <a:xfrm>
-            <a:off x="4663440" y="1143000"/>
-            <a:ext cx="4023360" cy="3520440"/>
-          </a:xfrm>
-          <a:prstGeom prst="rect">
-            <a:avLst/>
-          </a:prstGeom>
-          <a:solidFill>
-            <a:srgbClr val="1A1F35"/>
-          </a:solidFill>
-          <a:ln w="12700">
-            <a:solidFill>
-              <a:srgbClr val="5C55E8"/>
-            </a:solidFill>
-            <a:prstDash val="solid"/>
-          </a:ln>
-          <a:effectLst>
-            <a:outerShdw blurRad="152400" dist="50800" dir="8100000" algn="bl" rotWithShape="0">
-              <a:srgbClr val="000000">
-                <a:alpha val="40000"/>
-              </a:srgbClr>
-            </a:outerShdw>
-          </a:effectLst>
-        </p:spPr>
-      </p:sp>
-      <p:sp>
-        <p:nvSpPr>
-          <p:cNvPr id="15" name="Shape 13"/>
-          <p:cNvSpPr/>
-          <p:nvPr/>
-        </p:nvSpPr>
-        <p:spPr>
-          <a:xfrm>
-            <a:off x="4663440" y="1143000"/>
-            <a:ext cx="4023360" cy="54864"/>
-          </a:xfrm>
-          <a:prstGeom prst="rect">
-            <a:avLst/>
-          </a:prstGeom>
-          <a:solidFill>
-            <a:srgbClr val="5C55E8"/>
-          </a:solidFill>
-          <a:ln/>
-        </p:spPr>
-      </p:sp>
-      <p:sp>
-        <p:nvSpPr>
-          <p:cNvPr id="16" name="Text 14"/>
-          <p:cNvSpPr/>
-          <p:nvPr/>
-        </p:nvSpPr>
-        <p:spPr>
-          <a:xfrm>
-            <a:off x="4754880" y="1261872"/>
-            <a:ext cx="3840480" cy="411480"/>
-          </a:xfrm>
-          <a:prstGeom prst="rect">
-            <a:avLst/>
-          </a:prstGeom>
-          <a:noFill/>
-          <a:ln/>
-        </p:spPr>
-        <p:txBody>
-          <a:bodyPr wrap="square" lIns="0" tIns="0" rIns="0" bIns="0" rtlCol="0" anchor="ctr"/>
-          <a:lstStyle/>
-          <a:p>
-            <a:pPr marL="0" indent="0" algn="ctr">
-              <a:buNone/>
-            </a:pPr>
-            <a:r>
-              <a:rPr lang="en-US" sz="2000" b="1" kern="0" spc="200" dirty="0">
-                <a:solidFill>
-                  <a:srgbClr val="5C55E8"/>
-                </a:solidFill>
-                <a:latin typeface="Calibri" pitchFamily="34" charset="0"/>
-                <a:ea typeface="Calibri" pitchFamily="34" charset="-122"/>
-                <a:cs typeface="Calibri" pitchFamily="34" charset="-120"/>
-              </a:rPr>
-              <a:t>PREMIUM</a:t>
-            </a:r>
-            <a:endParaRPr lang="en-US" sz="2000" dirty="0"/>
-          </a:p>
-        </p:txBody>
-      </p:sp>
-      <p:sp>
-        <p:nvSpPr>
-          <p:cNvPr id="17" name="Text 15"/>
-          <p:cNvSpPr/>
-          <p:nvPr/>
-        </p:nvSpPr>
-        <p:spPr>
-          <a:xfrm>
-            <a:off x="4754880" y="1691640"/>
-            <a:ext cx="3840480" cy="457200"/>
-          </a:xfrm>
-          <a:prstGeom prst="rect">
-            <a:avLst/>
-          </a:prstGeom>
-          <a:noFill/>
-          <a:ln/>
-        </p:spPr>
-        <p:txBody>
-          <a:bodyPr wrap="square" lIns="0" tIns="0" rIns="0" bIns="0" rtlCol="0" anchor="ctr"/>
-          <a:lstStyle/>
-          <a:p>
-            <a:pPr marL="0" indent="0" algn="ctr">
-              <a:buNone/>
-            </a:pPr>
-            <a:r>
-              <a:rPr lang="en-US" sz="2400" b="1" dirty="0">
-                <a:solidFill>
-                  <a:srgbClr val="FFFFFF"/>
-                </a:solidFill>
-                <a:latin typeface="Calibri" pitchFamily="34" charset="0"/>
-                <a:ea typeface="Calibri" pitchFamily="34" charset="-122"/>
-                <a:cs typeface="Calibri" pitchFamily="34" charset="-120"/>
-              </a:rPr>
-              <a:t>€4.99/lună</a:t>
-            </a:r>
-            <a:endParaRPr lang="en-US" sz="2400" dirty="0"/>
-          </a:p>
-        </p:txBody>
-      </p:sp>
-      <p:sp>
-        <p:nvSpPr>
-          <p:cNvPr id="18" name="Text 16"/>
-          <p:cNvSpPr/>
-          <p:nvPr/>
-        </p:nvSpPr>
-        <p:spPr>
-          <a:xfrm>
-            <a:off x="4754880" y="2304288"/>
-            <a:ext cx="3840480" cy="329184"/>
-          </a:xfrm>
-          <a:prstGeom prst="rect">
-            <a:avLst/>
-          </a:prstGeom>
-          <a:noFill/>
-          <a:ln/>
-        </p:spPr>
-        <p:txBody>
-          <a:bodyPr wrap="square" lIns="0" tIns="0" rIns="0" bIns="0" rtlCol="0" anchor="ctr"/>
-          <a:lstStyle/>
-          <a:p>
-            <a:pPr marL="0" indent="0">
-              <a:buNone/>
-            </a:pPr>
-            <a:r>
-              <a:rPr lang="en-US" sz="1200" dirty="0">
-                <a:solidFill>
-                  <a:srgbClr val="00C4D4"/>
-                </a:solidFill>
-                <a:latin typeface="Calibri" pitchFamily="34" charset="0"/>
-                <a:ea typeface="Calibri" pitchFamily="34" charset="-122"/>
-                <a:cs typeface="Calibri" pitchFamily="34" charset="-120"/>
-              </a:rPr>
-              <a:t>✦  Timer 1–120 min personalizabil</a:t>
-            </a:r>
-            <a:endParaRPr lang="en-US" sz="1200" dirty="0"/>
-          </a:p>
-        </p:txBody>
-      </p:sp>
-      <p:sp>
-        <p:nvSpPr>
-          <p:cNvPr id="19" name="Text 17"/>
-          <p:cNvSpPr/>
-          <p:nvPr/>
-        </p:nvSpPr>
-        <p:spPr>
-          <a:xfrm>
-            <a:off x="4754880" y="2688336"/>
-            <a:ext cx="3840480" cy="329184"/>
-          </a:xfrm>
-          <a:prstGeom prst="rect">
-            <a:avLst/>
-          </a:prstGeom>
-          <a:noFill/>
-          <a:ln/>
-        </p:spPr>
-        <p:txBody>
-          <a:bodyPr wrap="square" lIns="0" tIns="0" rIns="0" bIns="0" rtlCol="0" anchor="ctr"/>
-          <a:lstStyle/>
-          <a:p>
-            <a:pPr marL="0" indent="0">
-              <a:buNone/>
-            </a:pPr>
-            <a:r>
-              <a:rPr lang="en-US" sz="1200" dirty="0">
-                <a:solidFill>
-                  <a:srgbClr val="00C4D4"/>
-                </a:solidFill>
-                <a:latin typeface="Calibri" pitchFamily="34" charset="0"/>
-                <a:ea typeface="Calibri" pitchFamily="34" charset="-122"/>
-                <a:cs typeface="Calibri" pitchFamily="34" charset="-120"/>
-              </a:rPr>
-              <a:t>✦  Statistici complete + export CSV</a:t>
-            </a:r>
-            <a:endParaRPr lang="en-US" sz="1200" dirty="0"/>
-          </a:p>
-        </p:txBody>
-      </p:sp>
-      <p:sp>
-        <p:nvSpPr>
-          <p:cNvPr id="20" name="Text 18"/>
-          <p:cNvSpPr/>
-          <p:nvPr/>
-        </p:nvSpPr>
-        <p:spPr>
-          <a:xfrm>
-            <a:off x="4754880" y="3072384"/>
-            <a:ext cx="3840480" cy="329184"/>
-          </a:xfrm>
-          <a:prstGeom prst="rect">
-            <a:avLst/>
-          </a:prstGeom>
-          <a:noFill/>
-          <a:ln/>
-        </p:spPr>
-        <p:txBody>
-          <a:bodyPr wrap="square" lIns="0" tIns="0" rIns="0" bIns="0" rtlCol="0" anchor="ctr"/>
-          <a:lstStyle/>
-          <a:p>
-            <a:pPr marL="0" indent="0">
-              <a:buNone/>
-            </a:pPr>
-            <a:r>
-              <a:rPr lang="en-US" sz="1200" dirty="0">
-                <a:solidFill>
-                  <a:srgbClr val="00C4D4"/>
-                </a:solidFill>
-                <a:latin typeface="Calibri" pitchFamily="34" charset="0"/>
-                <a:ea typeface="Calibri" pitchFamily="34" charset="-122"/>
-                <a:cs typeface="Calibri" pitchFamily="34" charset="-120"/>
-              </a:rPr>
-              <a:t>✦  Task-uri nelimitate + categorii</a:t>
-            </a:r>
-            <a:endParaRPr lang="en-US" sz="1200" dirty="0"/>
-          </a:p>
-        </p:txBody>
-      </p:sp>
-      <p:sp>
-        <p:nvSpPr>
-          <p:cNvPr id="21" name="Text 19"/>
-          <p:cNvSpPr/>
-          <p:nvPr/>
-        </p:nvSpPr>
-        <p:spPr>
-          <a:xfrm>
-            <a:off x="4754880" y="3456432"/>
-            <a:ext cx="3840480" cy="329184"/>
-          </a:xfrm>
-          <a:prstGeom prst="rect">
-            <a:avLst/>
-          </a:prstGeom>
-          <a:noFill/>
-          <a:ln/>
-        </p:spPr>
-        <p:txBody>
-          <a:bodyPr wrap="square" lIns="0" tIns="0" rIns="0" bIns="0" rtlCol="0" anchor="ctr"/>
-          <a:lstStyle/>
-          <a:p>
-            <a:pPr marL="0" indent="0">
-              <a:buNone/>
-            </a:pPr>
-            <a:r>
-              <a:rPr lang="en-US" sz="1200" dirty="0">
-                <a:solidFill>
-                  <a:srgbClr val="00C4D4"/>
-                </a:solidFill>
-                <a:latin typeface="Calibri" pitchFamily="34" charset="0"/>
-                <a:ea typeface="Calibri" pitchFamily="34" charset="-122"/>
-                <a:cs typeface="Calibri" pitchFamily="34" charset="-120"/>
-              </a:rPr>
-              <a:t>✦  Toate 8 gesturile giroscop</a:t>
-            </a:r>
-            <a:endParaRPr lang="en-US" sz="1200" dirty="0"/>
-          </a:p>
-        </p:txBody>
-      </p:sp>
-      <p:sp>
-        <p:nvSpPr>
-          <p:cNvPr id="22" name="Text 20"/>
-          <p:cNvSpPr/>
-          <p:nvPr/>
-        </p:nvSpPr>
-        <p:spPr>
-          <a:xfrm>
-            <a:off x="4754880" y="3840480"/>
-            <a:ext cx="3840480" cy="329184"/>
-          </a:xfrm>
-          <a:prstGeom prst="rect">
-            <a:avLst/>
-          </a:prstGeom>
-          <a:noFill/>
-          <a:ln/>
-        </p:spPr>
-        <p:txBody>
-          <a:bodyPr wrap="square" lIns="0" tIns="0" rIns="0" bIns="0" rtlCol="0" anchor="ctr"/>
-          <a:lstStyle/>
-          <a:p>
-            <a:pPr marL="0" indent="0">
-              <a:buNone/>
-            </a:pPr>
-            <a:r>
-              <a:rPr lang="en-US" sz="1200" dirty="0">
-                <a:solidFill>
-                  <a:srgbClr val="00C4D4"/>
-                </a:solidFill>
-                <a:latin typeface="Calibri" pitchFamily="34" charset="0"/>
-                <a:ea typeface="Calibri" pitchFamily="34" charset="-122"/>
-                <a:cs typeface="Calibri" pitchFamily="34" charset="-120"/>
-              </a:rPr>
-              <a:t>✦  30+ achievements + Leaderboard</a:t>
-            </a:r>
-            <a:endParaRPr lang="en-US" sz="1200" dirty="0"/>
-          </a:p>
-        </p:txBody>
-      </p:sp>
-      <p:sp>
-        <p:nvSpPr>
-          <p:cNvPr id="23" name="Text 21"/>
-          <p:cNvSpPr/>
-          <p:nvPr/>
-        </p:nvSpPr>
-        <p:spPr>
-          <a:xfrm>
-            <a:off x="4754880" y="4224528"/>
-            <a:ext cx="3840480" cy="329184"/>
-          </a:xfrm>
-          <a:prstGeom prst="rect">
-            <a:avLst/>
-          </a:prstGeom>
-          <a:noFill/>
-          <a:ln/>
-        </p:spPr>
-        <p:txBody>
-          <a:bodyPr wrap="square" lIns="0" tIns="0" rIns="0" bIns="0" rtlCol="0" anchor="ctr"/>
-          <a:lstStyle/>
-          <a:p>
-            <a:pPr marL="0" indent="0">
-              <a:buNone/>
-            </a:pPr>
-            <a:r>
-              <a:rPr lang="en-US" sz="1200" dirty="0">
-                <a:solidFill>
-                  <a:srgbClr val="00C4D4"/>
-                </a:solidFill>
-                <a:latin typeface="Calibri" pitchFamily="34" charset="0"/>
-                <a:ea typeface="Calibri" pitchFamily="34" charset="-122"/>
-                <a:cs typeface="Calibri" pitchFamily="34" charset="-120"/>
-              </a:rPr>
-              <a:t>✦  Cloud sync + backup automat</a:t>
-            </a:r>
-            <a:endParaRPr lang="en-US" sz="1200" dirty="0"/>
-          </a:p>
-        </p:txBody>
-      </p:sp>
-      <p:sp>
-        <p:nvSpPr>
-          <p:cNvPr id="24" name="Shape 22"/>
-          <p:cNvSpPr/>
-          <p:nvPr/>
-        </p:nvSpPr>
-        <p:spPr>
-          <a:xfrm>
-            <a:off x="0" y="4846320"/>
-            <a:ext cx="9144000" cy="297180"/>
-          </a:xfrm>
-          <a:prstGeom prst="rect">
-            <a:avLst/>
-          </a:prstGeom>
-          <a:solidFill>
-            <a:srgbClr val="1A2340"/>
-          </a:solidFill>
-          <a:ln/>
-        </p:spPr>
-      </p:sp>
-      <p:sp>
-        <p:nvSpPr>
-          <p:cNvPr id="25" name="Text 23"/>
-          <p:cNvSpPr/>
-          <p:nvPr/>
-        </p:nvSpPr>
-        <p:spPr>
-          <a:xfrm>
-            <a:off x="457200" y="4864608"/>
-            <a:ext cx="8229600" cy="256032"/>
-          </a:xfrm>
-          <a:prstGeom prst="rect">
-            <a:avLst/>
-          </a:prstGeom>
-          <a:noFill/>
-          <a:ln/>
-        </p:spPr>
-        <p:txBody>
-          <a:bodyPr wrap="square" lIns="0" tIns="0" rIns="0" bIns="0" rtlCol="0" anchor="ctr"/>
-          <a:lstStyle/>
-          <a:p>
-            <a:pPr marL="0" indent="0">
-              <a:buNone/>
-            </a:pPr>
-            <a:r>
-              <a:rPr lang="en-US" sz="900" dirty="0">
-                <a:solidFill>
-                  <a:srgbClr val="8892A4"/>
-                </a:solidFill>
-                <a:latin typeface="Calibri" pitchFamily="34" charset="0"/>
-                <a:ea typeface="Calibri" pitchFamily="34" charset="-122"/>
-                <a:cs typeface="Calibri" pitchFamily="34" charset="-120"/>
-              </a:rPr>
-              <a:t>KARA · Deep Work Platform</a:t>
-            </a:r>
-            <a:endParaRPr lang="en-US" sz="900" dirty="0"/>
-          </a:p>
-        </p:txBody>
-      </p:sp>
-    </p:spTree>
-  </p:cSld>
-  <p:clrMapOvr>
-    <a:masterClrMapping/>
-  </p:clrMapOvr>
-</p:sld>
-</file>
-
-<file path=ppt/slides/slide9.xml><?xml version="1.0" encoding="utf-8"?>
 <p:sld xmlns:a="http://schemas.openxmlformats.org/drawingml/2006/main" xmlns:r="http://schemas.openxmlformats.org/officeDocument/2006/relationships" xmlns:p="http://schemas.openxmlformats.org/presentationml/2006/main">
   <p:cSld name="Slide 9">
     <p:bg>

</xml_diff>